<commit_message>
Rebuild windowing slide with before/after visual
</commit_message>
<xml_diff>
--- a/docs/presentation.pptx
+++ b/docs/presentation.pptx
@@ -9264,7 +9264,46 @@
         </p:nvSpPr>
         <p:spPr>
           <a:xfrm>
-            <a:off x="731520" y="274320"/>
+            <a:off x="731520" y="137160"/>
+            <a:ext cx="7680960" cy="365760"/>
+          </a:xfrm>
+          <a:prstGeom prst="rect">
+            <a:avLst/>
+          </a:prstGeom>
+          <a:noFill/>
+          <a:ln/>
+        </p:spPr>
+        <p:txBody>
+          <a:bodyPr wrap="square" lIns="0" tIns="0" rIns="0" bIns="0" rtlCol="0" anchor="ctr"/>
+          <a:lstStyle/>
+          <a:p>
+            <a:pPr indent="0" marL="0">
+              <a:buNone/>
+            </a:pPr>
+            <a:r>
+              <a:rPr lang="en-US" sz="1400" b="1" dirty="0">
+                <a:solidFill>
+                  <a:srgbClr val="F39C12"/>
+                </a:solidFill>
+                <a:latin typeface="Calibri" pitchFamily="34" charset="0"/>
+                <a:ea typeface="Calibri" pitchFamily="34" charset="-122"/>
+                <a:cs typeface="Calibri" pitchFamily="34" charset="-120"/>
+              </a:rPr>
+              <a:t>Spark Structured Streaming</a:t>
+            </a:r>
+            <a:endParaRPr lang="en-US" sz="1400" dirty="0"/>
+          </a:p>
+        </p:txBody>
+      </p:sp>
+      <p:sp>
+        <p:nvSpPr>
+          <p:cNvPr id="4" name="Text 2"/>
+          <p:cNvSpPr/>
+          <p:nvPr/>
+        </p:nvSpPr>
+        <p:spPr>
+          <a:xfrm>
+            <a:off x="731520" y="457200"/>
             <a:ext cx="7680960" cy="457200"/>
           </a:xfrm>
           <a:prstGeom prst="rect">
@@ -9281,46 +9320,7 @@
               <a:buNone/>
             </a:pPr>
             <a:r>
-              <a:rPr lang="en-US" sz="1400" b="1" dirty="0">
-                <a:solidFill>
-                  <a:srgbClr val="F39C12"/>
-                </a:solidFill>
-                <a:latin typeface="Calibri" pitchFamily="34" charset="0"/>
-                <a:ea typeface="Calibri" pitchFamily="34" charset="-122"/>
-                <a:cs typeface="Calibri" pitchFamily="34" charset="-120"/>
-              </a:rPr>
-              <a:t>Spark Structured Streaming</a:t>
-            </a:r>
-            <a:endParaRPr lang="en-US" sz="1400" dirty="0"/>
-          </a:p>
-        </p:txBody>
-      </p:sp>
-      <p:sp>
-        <p:nvSpPr>
-          <p:cNvPr id="4" name="Text 2"/>
-          <p:cNvSpPr/>
-          <p:nvPr/>
-        </p:nvSpPr>
-        <p:spPr>
-          <a:xfrm>
-            <a:off x="731520" y="640080"/>
-            <a:ext cx="7680960" cy="548640"/>
-          </a:xfrm>
-          <a:prstGeom prst="rect">
-            <a:avLst/>
-          </a:prstGeom>
-          <a:noFill/>
-          <a:ln/>
-        </p:spPr>
-        <p:txBody>
-          <a:bodyPr wrap="square" lIns="0" tIns="0" rIns="0" bIns="0" rtlCol="0" anchor="ctr"/>
-          <a:lstStyle/>
-          <a:p>
-            <a:pPr indent="0" marL="0">
-              <a:buNone/>
-            </a:pPr>
-            <a:r>
-              <a:rPr lang="en-US" sz="3200" b="1" dirty="0">
+              <a:rPr lang="en-US" sz="3000" b="1" dirty="0">
                 <a:solidFill>
                   <a:srgbClr val="FFFFFF"/>
                 </a:solidFill>
@@ -9328,9 +9328,9 @@
                 <a:ea typeface="Georgia" pitchFamily="34" charset="-122"/>
                 <a:cs typeface="Georgia" pitchFamily="34" charset="-120"/>
               </a:rPr>
-              <a:t>Risk Detection with Windowing</a:t>
-            </a:r>
-            <a:endParaRPr lang="en-US" sz="3200" dirty="0"/>
+              <a:t>What Windowing Does</a:t>
+            </a:r>
+            <a:endParaRPr lang="en-US" sz="3000" dirty="0"/>
           </a:p>
         </p:txBody>
       </p:sp>
@@ -9342,34 +9342,34 @@
         </p:nvSpPr>
         <p:spPr>
           <a:xfrm>
-            <a:off x="731520" y="1371600"/>
-            <a:ext cx="7680960" cy="365760"/>
-          </a:xfrm>
-          <a:prstGeom prst="rect">
-            <a:avLst/>
-          </a:prstGeom>
-          <a:noFill/>
-          <a:ln/>
-        </p:spPr>
-        <p:txBody>
-          <a:bodyPr wrap="square" lIns="0" tIns="0" rIns="0" bIns="0" rtlCol="0" anchor="ctr"/>
-          <a:lstStyle/>
-          <a:p>
-            <a:pPr indent="0" marL="0">
-              <a:buNone/>
-            </a:pPr>
-            <a:r>
-              <a:rPr lang="en-US" sz="1600" b="1" dirty="0">
-                <a:solidFill>
-                  <a:srgbClr val="FFFFFF"/>
-                </a:solidFill>
-                <a:latin typeface="Calibri" pitchFamily="34" charset="0"/>
-                <a:ea typeface="Calibri" pitchFamily="34" charset="-122"/>
-                <a:cs typeface="Calibri" pitchFamily="34" charset="-120"/>
-              </a:rPr>
-              <a:t>60-Second Tumbling Windows</a:t>
-            </a:r>
-            <a:endParaRPr lang="en-US" sz="1600" dirty="0"/>
+            <a:off x="365760" y="1005840"/>
+            <a:ext cx="4023360" cy="274320"/>
+          </a:xfrm>
+          <a:prstGeom prst="rect">
+            <a:avLst/>
+          </a:prstGeom>
+          <a:noFill/>
+          <a:ln/>
+        </p:spPr>
+        <p:txBody>
+          <a:bodyPr wrap="square" lIns="0" tIns="0" rIns="0" bIns="0" rtlCol="0" anchor="ctr"/>
+          <a:lstStyle/>
+          <a:p>
+            <a:pPr algn="ctr" indent="0" marL="0">
+              <a:buNone/>
+            </a:pPr>
+            <a:r>
+              <a:rPr lang="en-US" sz="1300" b="1" dirty="0">
+                <a:solidFill>
+                  <a:srgbClr val="718096"/>
+                </a:solidFill>
+                <a:latin typeface="Calibri" pitchFamily="34" charset="0"/>
+                <a:ea typeface="Calibri" pitchFamily="34" charset="-122"/>
+                <a:cs typeface="Calibri" pitchFamily="34" charset="-120"/>
+              </a:rPr>
+              <a:t>Raw Order Stream</a:t>
+            </a:r>
+            <a:endParaRPr lang="en-US" sz="1300" dirty="0"/>
           </a:p>
         </p:txBody>
       </p:sp>
@@ -9381,20 +9381,18 @@
         </p:nvSpPr>
         <p:spPr>
           <a:xfrm>
-            <a:off x="731520" y="1828800"/>
-            <a:ext cx="2560320" cy="914400"/>
-          </a:xfrm>
-          <a:prstGeom prst="rect">
-            <a:avLst/>
-          </a:prstGeom>
-          <a:solidFill>
-            <a:srgbClr val="232842"/>
-          </a:solidFill>
-          <a:ln w="25400">
+            <a:off x="548640" y="2468880"/>
+            <a:ext cx="3657600" cy="0"/>
+          </a:xfrm>
+          <a:prstGeom prst="line">
+            <a:avLst/>
+          </a:prstGeom>
+          <a:noFill/>
+          <a:ln w="12700">
             <a:solidFill>
-              <a:srgbClr val="4A90D9"/>
+              <a:srgbClr val="718096"/>
             </a:solidFill>
-            <a:prstDash val="solid"/>
+            <a:prstDash val="dash"/>
           </a:ln>
         </p:spPr>
       </p:sp>
@@ -9406,49 +9404,649 @@
         </p:nvSpPr>
         <p:spPr>
           <a:xfrm>
-            <a:off x="731520" y="1828800"/>
-            <a:ext cx="2560320" cy="457200"/>
-          </a:xfrm>
-          <a:prstGeom prst="rect">
-            <a:avLst/>
-          </a:prstGeom>
-          <a:noFill/>
-          <a:ln/>
-        </p:spPr>
-        <p:txBody>
-          <a:bodyPr wrap="square" lIns="0" tIns="0" rIns="0" bIns="0" rtlCol="0" anchor="ctr"/>
-          <a:lstStyle/>
-          <a:p>
-            <a:pPr algn="ctr" indent="0" marL="0">
-              <a:buNone/>
-            </a:pPr>
-            <a:r>
-              <a:rPr lang="en-US" sz="1000" dirty="0">
-                <a:solidFill>
-                  <a:srgbClr val="4A90D9"/>
+            <a:off x="365760" y="2560320"/>
+            <a:ext cx="457200" cy="228600"/>
+          </a:xfrm>
+          <a:prstGeom prst="rect">
+            <a:avLst/>
+          </a:prstGeom>
+          <a:noFill/>
+          <a:ln/>
+        </p:spPr>
+        <p:txBody>
+          <a:bodyPr wrap="square" lIns="0" tIns="0" rIns="0" bIns="0" rtlCol="0" anchor="ctr"/>
+          <a:lstStyle/>
+          <a:p>
+            <a:pPr indent="0" marL="0">
+              <a:buNone/>
+            </a:pPr>
+            <a:r>
+              <a:rPr lang="en-US" sz="900" dirty="0">
+                <a:solidFill>
+                  <a:srgbClr val="718096"/>
                 </a:solidFill>
                 <a:latin typeface="Consolas" pitchFamily="34" charset="0"/>
                 <a:ea typeface="Consolas" pitchFamily="34" charset="-122"/>
                 <a:cs typeface="Consolas" pitchFamily="34" charset="-120"/>
               </a:rPr>
-              <a:t>Window 1</a:t>
-            </a:r>
-            <a:endParaRPr lang="en-US" sz="1000" dirty="0"/>
-          </a:p>
-          <a:p>
-            <a:pPr algn="ctr" indent="0" marL="0">
-              <a:buNone/>
-            </a:pPr>
-            <a:r>
-              <a:rPr lang="en-US" sz="1000" dirty="0">
-                <a:solidFill>
-                  <a:srgbClr val="4A90D9"/>
+              <a:t>:00</a:t>
+            </a:r>
+            <a:endParaRPr lang="en-US" sz="900" dirty="0"/>
+          </a:p>
+        </p:txBody>
+      </p:sp>
+      <p:sp>
+        <p:nvSpPr>
+          <p:cNvPr id="8" name="Text 6"/>
+          <p:cNvSpPr/>
+          <p:nvPr/>
+        </p:nvSpPr>
+        <p:spPr>
+          <a:xfrm>
+            <a:off x="2103120" y="2560320"/>
+            <a:ext cx="457200" cy="228600"/>
+          </a:xfrm>
+          <a:prstGeom prst="rect">
+            <a:avLst/>
+          </a:prstGeom>
+          <a:noFill/>
+          <a:ln/>
+        </p:spPr>
+        <p:txBody>
+          <a:bodyPr wrap="square" lIns="0" tIns="0" rIns="0" bIns="0" rtlCol="0" anchor="ctr"/>
+          <a:lstStyle/>
+          <a:p>
+            <a:pPr indent="0" marL="0">
+              <a:buNone/>
+            </a:pPr>
+            <a:r>
+              <a:rPr lang="en-US" sz="900" dirty="0">
+                <a:solidFill>
+                  <a:srgbClr val="718096"/>
                 </a:solidFill>
                 <a:latin typeface="Consolas" pitchFamily="34" charset="0"/>
                 <a:ea typeface="Consolas" pitchFamily="34" charset="-122"/>
                 <a:cs typeface="Consolas" pitchFamily="34" charset="-120"/>
               </a:rPr>
-              <a:t>:00 – :60</a:t>
+              <a:t>:30</a:t>
+            </a:r>
+            <a:endParaRPr lang="en-US" sz="900" dirty="0"/>
+          </a:p>
+        </p:txBody>
+      </p:sp>
+      <p:sp>
+        <p:nvSpPr>
+          <p:cNvPr id="9" name="Text 7"/>
+          <p:cNvSpPr/>
+          <p:nvPr/>
+        </p:nvSpPr>
+        <p:spPr>
+          <a:xfrm>
+            <a:off x="3840480" y="2560320"/>
+            <a:ext cx="457200" cy="228600"/>
+          </a:xfrm>
+          <a:prstGeom prst="rect">
+            <a:avLst/>
+          </a:prstGeom>
+          <a:noFill/>
+          <a:ln/>
+        </p:spPr>
+        <p:txBody>
+          <a:bodyPr wrap="square" lIns="0" tIns="0" rIns="0" bIns="0" rtlCol="0" anchor="ctr"/>
+          <a:lstStyle/>
+          <a:p>
+            <a:pPr indent="0" marL="0">
+              <a:buNone/>
+            </a:pPr>
+            <a:r>
+              <a:rPr lang="en-US" sz="900" dirty="0">
+                <a:solidFill>
+                  <a:srgbClr val="718096"/>
+                </a:solidFill>
+                <a:latin typeface="Consolas" pitchFamily="34" charset="0"/>
+                <a:ea typeface="Consolas" pitchFamily="34" charset="-122"/>
+                <a:cs typeface="Consolas" pitchFamily="34" charset="-120"/>
+              </a:rPr>
+              <a:t>:60</a:t>
+            </a:r>
+            <a:endParaRPr lang="en-US" sz="900" dirty="0"/>
+          </a:p>
+        </p:txBody>
+      </p:sp>
+      <p:sp>
+        <p:nvSpPr>
+          <p:cNvPr id="10" name="Shape 8"/>
+          <p:cNvSpPr/>
+          <p:nvPr/>
+        </p:nvSpPr>
+        <p:spPr>
+          <a:xfrm>
+            <a:off x="640080" y="1463040"/>
+            <a:ext cx="91440" cy="91440"/>
+          </a:xfrm>
+          <a:prstGeom prst="ellipse">
+            <a:avLst/>
+          </a:prstGeom>
+          <a:solidFill>
+            <a:srgbClr val="4A90D9"/>
+          </a:solidFill>
+          <a:ln/>
+        </p:spPr>
+      </p:sp>
+      <p:sp>
+        <p:nvSpPr>
+          <p:cNvPr id="11" name="Shape 9"/>
+          <p:cNvSpPr/>
+          <p:nvPr/>
+        </p:nvSpPr>
+        <p:spPr>
+          <a:xfrm>
+            <a:off x="822960" y="1920240"/>
+            <a:ext cx="91440" cy="91440"/>
+          </a:xfrm>
+          <a:prstGeom prst="ellipse">
+            <a:avLst/>
+          </a:prstGeom>
+          <a:solidFill>
+            <a:srgbClr val="27AE60"/>
+          </a:solidFill>
+          <a:ln/>
+        </p:spPr>
+      </p:sp>
+      <p:sp>
+        <p:nvSpPr>
+          <p:cNvPr id="12" name="Shape 10"/>
+          <p:cNvSpPr/>
+          <p:nvPr/>
+        </p:nvSpPr>
+        <p:spPr>
+          <a:xfrm>
+            <a:off x="1005840" y="1645920"/>
+            <a:ext cx="91440" cy="91440"/>
+          </a:xfrm>
+          <a:prstGeom prst="ellipse">
+            <a:avLst/>
+          </a:prstGeom>
+          <a:solidFill>
+            <a:srgbClr val="F39C12"/>
+          </a:solidFill>
+          <a:ln/>
+        </p:spPr>
+      </p:sp>
+      <p:sp>
+        <p:nvSpPr>
+          <p:cNvPr id="13" name="Shape 11"/>
+          <p:cNvSpPr/>
+          <p:nvPr/>
+        </p:nvSpPr>
+        <p:spPr>
+          <a:xfrm>
+            <a:off x="1097280" y="2194560"/>
+            <a:ext cx="91440" cy="91440"/>
+          </a:xfrm>
+          <a:prstGeom prst="ellipse">
+            <a:avLst/>
+          </a:prstGeom>
+          <a:solidFill>
+            <a:srgbClr val="E74C3C"/>
+          </a:solidFill>
+          <a:ln/>
+        </p:spPr>
+      </p:sp>
+      <p:sp>
+        <p:nvSpPr>
+          <p:cNvPr id="14" name="Shape 12"/>
+          <p:cNvSpPr/>
+          <p:nvPr/>
+        </p:nvSpPr>
+        <p:spPr>
+          <a:xfrm>
+            <a:off x="1280160" y="1371600"/>
+            <a:ext cx="91440" cy="91440"/>
+          </a:xfrm>
+          <a:prstGeom prst="ellipse">
+            <a:avLst/>
+          </a:prstGeom>
+          <a:solidFill>
+            <a:srgbClr val="9B59B6"/>
+          </a:solidFill>
+          <a:ln/>
+        </p:spPr>
+      </p:sp>
+      <p:sp>
+        <p:nvSpPr>
+          <p:cNvPr id="15" name="Shape 13"/>
+          <p:cNvSpPr/>
+          <p:nvPr/>
+        </p:nvSpPr>
+        <p:spPr>
+          <a:xfrm>
+            <a:off x="1463040" y="1828800"/>
+            <a:ext cx="91440" cy="91440"/>
+          </a:xfrm>
+          <a:prstGeom prst="ellipse">
+            <a:avLst/>
+          </a:prstGeom>
+          <a:solidFill>
+            <a:srgbClr val="4A90D9"/>
+          </a:solidFill>
+          <a:ln/>
+        </p:spPr>
+      </p:sp>
+      <p:sp>
+        <p:nvSpPr>
+          <p:cNvPr id="16" name="Shape 14"/>
+          <p:cNvSpPr/>
+          <p:nvPr/>
+        </p:nvSpPr>
+        <p:spPr>
+          <a:xfrm>
+            <a:off x="1554480" y="1554480"/>
+            <a:ext cx="91440" cy="91440"/>
+          </a:xfrm>
+          <a:prstGeom prst="ellipse">
+            <a:avLst/>
+          </a:prstGeom>
+          <a:solidFill>
+            <a:srgbClr val="27AE60"/>
+          </a:solidFill>
+          <a:ln/>
+        </p:spPr>
+      </p:sp>
+      <p:sp>
+        <p:nvSpPr>
+          <p:cNvPr id="17" name="Shape 15"/>
+          <p:cNvSpPr/>
+          <p:nvPr/>
+        </p:nvSpPr>
+        <p:spPr>
+          <a:xfrm>
+            <a:off x="1737360" y="2103120"/>
+            <a:ext cx="91440" cy="91440"/>
+          </a:xfrm>
+          <a:prstGeom prst="ellipse">
+            <a:avLst/>
+          </a:prstGeom>
+          <a:solidFill>
+            <a:srgbClr val="F39C12"/>
+          </a:solidFill>
+          <a:ln/>
+        </p:spPr>
+      </p:sp>
+      <p:sp>
+        <p:nvSpPr>
+          <p:cNvPr id="18" name="Shape 16"/>
+          <p:cNvSpPr/>
+          <p:nvPr/>
+        </p:nvSpPr>
+        <p:spPr>
+          <a:xfrm>
+            <a:off x="1828800" y="1737360"/>
+            <a:ext cx="91440" cy="91440"/>
+          </a:xfrm>
+          <a:prstGeom prst="ellipse">
+            <a:avLst/>
+          </a:prstGeom>
+          <a:solidFill>
+            <a:srgbClr val="E74C3C"/>
+          </a:solidFill>
+          <a:ln/>
+        </p:spPr>
+      </p:sp>
+      <p:sp>
+        <p:nvSpPr>
+          <p:cNvPr id="19" name="Shape 17"/>
+          <p:cNvSpPr/>
+          <p:nvPr/>
+        </p:nvSpPr>
+        <p:spPr>
+          <a:xfrm>
+            <a:off x="2011680" y="1463040"/>
+            <a:ext cx="91440" cy="91440"/>
+          </a:xfrm>
+          <a:prstGeom prst="ellipse">
+            <a:avLst/>
+          </a:prstGeom>
+          <a:solidFill>
+            <a:srgbClr val="9B59B6"/>
+          </a:solidFill>
+          <a:ln/>
+        </p:spPr>
+      </p:sp>
+      <p:sp>
+        <p:nvSpPr>
+          <p:cNvPr id="20" name="Shape 18"/>
+          <p:cNvSpPr/>
+          <p:nvPr/>
+        </p:nvSpPr>
+        <p:spPr>
+          <a:xfrm>
+            <a:off x="2103120" y="2011680"/>
+            <a:ext cx="91440" cy="91440"/>
+          </a:xfrm>
+          <a:prstGeom prst="ellipse">
+            <a:avLst/>
+          </a:prstGeom>
+          <a:solidFill>
+            <a:srgbClr val="4A90D9"/>
+          </a:solidFill>
+          <a:ln/>
+        </p:spPr>
+      </p:sp>
+      <p:sp>
+        <p:nvSpPr>
+          <p:cNvPr id="21" name="Shape 19"/>
+          <p:cNvSpPr/>
+          <p:nvPr/>
+        </p:nvSpPr>
+        <p:spPr>
+          <a:xfrm>
+            <a:off x="2286000" y="2286000"/>
+            <a:ext cx="91440" cy="91440"/>
+          </a:xfrm>
+          <a:prstGeom prst="ellipse">
+            <a:avLst/>
+          </a:prstGeom>
+          <a:solidFill>
+            <a:srgbClr val="27AE60"/>
+          </a:solidFill>
+          <a:ln/>
+        </p:spPr>
+      </p:sp>
+      <p:sp>
+        <p:nvSpPr>
+          <p:cNvPr id="22" name="Shape 20"/>
+          <p:cNvSpPr/>
+          <p:nvPr/>
+        </p:nvSpPr>
+        <p:spPr>
+          <a:xfrm>
+            <a:off x="2377440" y="1645920"/>
+            <a:ext cx="91440" cy="91440"/>
+          </a:xfrm>
+          <a:prstGeom prst="ellipse">
+            <a:avLst/>
+          </a:prstGeom>
+          <a:solidFill>
+            <a:srgbClr val="F39C12"/>
+          </a:solidFill>
+          <a:ln/>
+        </p:spPr>
+      </p:sp>
+      <p:sp>
+        <p:nvSpPr>
+          <p:cNvPr id="23" name="Shape 21"/>
+          <p:cNvSpPr/>
+          <p:nvPr/>
+        </p:nvSpPr>
+        <p:spPr>
+          <a:xfrm>
+            <a:off x="2560320" y="1920240"/>
+            <a:ext cx="91440" cy="91440"/>
+          </a:xfrm>
+          <a:prstGeom prst="ellipse">
+            <a:avLst/>
+          </a:prstGeom>
+          <a:solidFill>
+            <a:srgbClr val="E74C3C"/>
+          </a:solidFill>
+          <a:ln/>
+        </p:spPr>
+      </p:sp>
+      <p:sp>
+        <p:nvSpPr>
+          <p:cNvPr id="24" name="Shape 22"/>
+          <p:cNvSpPr/>
+          <p:nvPr/>
+        </p:nvSpPr>
+        <p:spPr>
+          <a:xfrm>
+            <a:off x="2651760" y="1371600"/>
+            <a:ext cx="91440" cy="91440"/>
+          </a:xfrm>
+          <a:prstGeom prst="ellipse">
+            <a:avLst/>
+          </a:prstGeom>
+          <a:solidFill>
+            <a:srgbClr val="9B59B6"/>
+          </a:solidFill>
+          <a:ln/>
+        </p:spPr>
+      </p:sp>
+      <p:sp>
+        <p:nvSpPr>
+          <p:cNvPr id="25" name="Shape 23"/>
+          <p:cNvSpPr/>
+          <p:nvPr/>
+        </p:nvSpPr>
+        <p:spPr>
+          <a:xfrm>
+            <a:off x="2834640" y="2194560"/>
+            <a:ext cx="91440" cy="91440"/>
+          </a:xfrm>
+          <a:prstGeom prst="ellipse">
+            <a:avLst/>
+          </a:prstGeom>
+          <a:solidFill>
+            <a:srgbClr val="4A90D9"/>
+          </a:solidFill>
+          <a:ln/>
+        </p:spPr>
+      </p:sp>
+      <p:sp>
+        <p:nvSpPr>
+          <p:cNvPr id="26" name="Shape 24"/>
+          <p:cNvSpPr/>
+          <p:nvPr/>
+        </p:nvSpPr>
+        <p:spPr>
+          <a:xfrm>
+            <a:off x="2926080" y="1554480"/>
+            <a:ext cx="91440" cy="91440"/>
+          </a:xfrm>
+          <a:prstGeom prst="ellipse">
+            <a:avLst/>
+          </a:prstGeom>
+          <a:solidFill>
+            <a:srgbClr val="27AE60"/>
+          </a:solidFill>
+          <a:ln/>
+        </p:spPr>
+      </p:sp>
+      <p:sp>
+        <p:nvSpPr>
+          <p:cNvPr id="27" name="Shape 25"/>
+          <p:cNvSpPr/>
+          <p:nvPr/>
+        </p:nvSpPr>
+        <p:spPr>
+          <a:xfrm>
+            <a:off x="3017520" y="1828800"/>
+            <a:ext cx="91440" cy="91440"/>
+          </a:xfrm>
+          <a:prstGeom prst="ellipse">
+            <a:avLst/>
+          </a:prstGeom>
+          <a:solidFill>
+            <a:srgbClr val="F39C12"/>
+          </a:solidFill>
+          <a:ln/>
+        </p:spPr>
+      </p:sp>
+      <p:sp>
+        <p:nvSpPr>
+          <p:cNvPr id="28" name="Shape 26"/>
+          <p:cNvSpPr/>
+          <p:nvPr/>
+        </p:nvSpPr>
+        <p:spPr>
+          <a:xfrm>
+            <a:off x="3200400" y="2103120"/>
+            <a:ext cx="91440" cy="91440"/>
+          </a:xfrm>
+          <a:prstGeom prst="ellipse">
+            <a:avLst/>
+          </a:prstGeom>
+          <a:solidFill>
+            <a:srgbClr val="E74C3C"/>
+          </a:solidFill>
+          <a:ln/>
+        </p:spPr>
+      </p:sp>
+      <p:sp>
+        <p:nvSpPr>
+          <p:cNvPr id="29" name="Shape 27"/>
+          <p:cNvSpPr/>
+          <p:nvPr/>
+        </p:nvSpPr>
+        <p:spPr>
+          <a:xfrm>
+            <a:off x="3291840" y="1463040"/>
+            <a:ext cx="91440" cy="91440"/>
+          </a:xfrm>
+          <a:prstGeom prst="ellipse">
+            <a:avLst/>
+          </a:prstGeom>
+          <a:solidFill>
+            <a:srgbClr val="9B59B6"/>
+          </a:solidFill>
+          <a:ln/>
+        </p:spPr>
+      </p:sp>
+      <p:sp>
+        <p:nvSpPr>
+          <p:cNvPr id="30" name="Shape 28"/>
+          <p:cNvSpPr/>
+          <p:nvPr/>
+        </p:nvSpPr>
+        <p:spPr>
+          <a:xfrm>
+            <a:off x="3383280" y="2286000"/>
+            <a:ext cx="91440" cy="91440"/>
+          </a:xfrm>
+          <a:prstGeom prst="ellipse">
+            <a:avLst/>
+          </a:prstGeom>
+          <a:solidFill>
+            <a:srgbClr val="4A90D9"/>
+          </a:solidFill>
+          <a:ln/>
+        </p:spPr>
+      </p:sp>
+      <p:sp>
+        <p:nvSpPr>
+          <p:cNvPr id="31" name="Shape 29"/>
+          <p:cNvSpPr/>
+          <p:nvPr/>
+        </p:nvSpPr>
+        <p:spPr>
+          <a:xfrm>
+            <a:off x="3566160" y="1737360"/>
+            <a:ext cx="91440" cy="91440"/>
+          </a:xfrm>
+          <a:prstGeom prst="ellipse">
+            <a:avLst/>
+          </a:prstGeom>
+          <a:solidFill>
+            <a:srgbClr val="27AE60"/>
+          </a:solidFill>
+          <a:ln/>
+        </p:spPr>
+      </p:sp>
+      <p:sp>
+        <p:nvSpPr>
+          <p:cNvPr id="32" name="Shape 30"/>
+          <p:cNvSpPr/>
+          <p:nvPr/>
+        </p:nvSpPr>
+        <p:spPr>
+          <a:xfrm>
+            <a:off x="3657600" y="2011680"/>
+            <a:ext cx="91440" cy="91440"/>
+          </a:xfrm>
+          <a:prstGeom prst="ellipse">
+            <a:avLst/>
+          </a:prstGeom>
+          <a:solidFill>
+            <a:srgbClr val="F39C12"/>
+          </a:solidFill>
+          <a:ln/>
+        </p:spPr>
+      </p:sp>
+      <p:sp>
+        <p:nvSpPr>
+          <p:cNvPr id="33" name="Shape 31"/>
+          <p:cNvSpPr/>
+          <p:nvPr/>
+        </p:nvSpPr>
+        <p:spPr>
+          <a:xfrm>
+            <a:off x="3840480" y="1645920"/>
+            <a:ext cx="91440" cy="91440"/>
+          </a:xfrm>
+          <a:prstGeom prst="ellipse">
+            <a:avLst/>
+          </a:prstGeom>
+          <a:solidFill>
+            <a:srgbClr val="E74C3C"/>
+          </a:solidFill>
+          <a:ln/>
+        </p:spPr>
+      </p:sp>
+      <p:sp>
+        <p:nvSpPr>
+          <p:cNvPr id="34" name="Shape 32"/>
+          <p:cNvSpPr/>
+          <p:nvPr/>
+        </p:nvSpPr>
+        <p:spPr>
+          <a:xfrm>
+            <a:off x="3931920" y="1920240"/>
+            <a:ext cx="91440" cy="91440"/>
+          </a:xfrm>
+          <a:prstGeom prst="ellipse">
+            <a:avLst/>
+          </a:prstGeom>
+          <a:solidFill>
+            <a:srgbClr val="9B59B6"/>
+          </a:solidFill>
+          <a:ln/>
+        </p:spPr>
+      </p:sp>
+      <p:sp>
+        <p:nvSpPr>
+          <p:cNvPr id="35" name="Text 33"/>
+          <p:cNvSpPr/>
+          <p:nvPr/>
+        </p:nvSpPr>
+        <p:spPr>
+          <a:xfrm>
+            <a:off x="365760" y="2834640"/>
+            <a:ext cx="4023360" cy="228600"/>
+          </a:xfrm>
+          <a:prstGeom prst="rect">
+            <a:avLst/>
+          </a:prstGeom>
+          <a:noFill/>
+          <a:ln/>
+        </p:spPr>
+        <p:txBody>
+          <a:bodyPr wrap="square" lIns="0" tIns="0" rIns="0" bIns="0" rtlCol="0" anchor="ctr"/>
+          <a:lstStyle/>
+          <a:p>
+            <a:pPr algn="ctr" indent="0" marL="0">
+              <a:buNone/>
+            </a:pPr>
+            <a:r>
+              <a:rPr lang="en-US" sz="1000" i="1" dirty="0">
+                <a:solidFill>
+                  <a:srgbClr val="718096"/>
+                </a:solidFill>
+                <a:latin typeface="Calibri" pitchFamily="34" charset="0"/>
+                <a:ea typeface="Calibri" pitchFamily="34" charset="-122"/>
+                <a:cs typeface="Calibri" pitchFamily="34" charset="-120"/>
+              </a:rPr>
+              <a:t>Individual orders — hard to see patterns</a:t>
             </a:r>
             <a:endParaRPr lang="en-US" sz="1000" dirty="0"/>
           </a:p>
@@ -9456,114 +10054,131 @@
       </p:sp>
       <p:sp>
         <p:nvSpPr>
-          <p:cNvPr id="8" name="Shape 6"/>
-          <p:cNvSpPr/>
-          <p:nvPr/>
-        </p:nvSpPr>
-        <p:spPr>
-          <a:xfrm>
-            <a:off x="914400" y="2286000"/>
-            <a:ext cx="109728" cy="109728"/>
-          </a:xfrm>
-          <a:prstGeom prst="ellipse">
-            <a:avLst/>
-          </a:prstGeom>
-          <a:solidFill>
-            <a:srgbClr val="4A90D9"/>
-          </a:solidFill>
-          <a:ln/>
-        </p:spPr>
-      </p:sp>
-      <p:sp>
-        <p:nvSpPr>
-          <p:cNvPr id="9" name="Shape 7"/>
-          <p:cNvSpPr/>
-          <p:nvPr/>
-        </p:nvSpPr>
-        <p:spPr>
-          <a:xfrm>
-            <a:off x="1234440" y="2286000"/>
-            <a:ext cx="109728" cy="109728"/>
-          </a:xfrm>
-          <a:prstGeom prst="ellipse">
-            <a:avLst/>
-          </a:prstGeom>
-          <a:solidFill>
-            <a:srgbClr val="4A90D9"/>
-          </a:solidFill>
-          <a:ln/>
-        </p:spPr>
-      </p:sp>
-      <p:sp>
-        <p:nvSpPr>
-          <p:cNvPr id="10" name="Shape 8"/>
-          <p:cNvSpPr/>
-          <p:nvPr/>
-        </p:nvSpPr>
-        <p:spPr>
-          <a:xfrm>
-            <a:off x="1554480" y="2286000"/>
-            <a:ext cx="109728" cy="109728"/>
-          </a:xfrm>
-          <a:prstGeom prst="ellipse">
-            <a:avLst/>
-          </a:prstGeom>
-          <a:solidFill>
-            <a:srgbClr val="4A90D9"/>
-          </a:solidFill>
-          <a:ln/>
-        </p:spPr>
-      </p:sp>
-      <p:sp>
-        <p:nvSpPr>
-          <p:cNvPr id="11" name="Shape 9"/>
-          <p:cNvSpPr/>
-          <p:nvPr/>
-        </p:nvSpPr>
-        <p:spPr>
-          <a:xfrm>
-            <a:off x="1874520" y="2286000"/>
-            <a:ext cx="109728" cy="109728"/>
-          </a:xfrm>
-          <a:prstGeom prst="ellipse">
-            <a:avLst/>
-          </a:prstGeom>
-          <a:solidFill>
-            <a:srgbClr val="4A90D9"/>
-          </a:solidFill>
-          <a:ln/>
-        </p:spPr>
-      </p:sp>
-      <p:sp>
-        <p:nvSpPr>
-          <p:cNvPr id="12" name="Shape 10"/>
-          <p:cNvSpPr/>
-          <p:nvPr/>
-        </p:nvSpPr>
-        <p:spPr>
-          <a:xfrm>
-            <a:off x="2194560" y="2286000"/>
-            <a:ext cx="109728" cy="109728"/>
-          </a:xfrm>
-          <a:prstGeom prst="ellipse">
-            <a:avLst/>
-          </a:prstGeom>
-          <a:solidFill>
-            <a:srgbClr val="4A90D9"/>
-          </a:solidFill>
-          <a:ln/>
-        </p:spPr>
-      </p:sp>
-      <p:sp>
-        <p:nvSpPr>
-          <p:cNvPr id="13" name="Shape 11"/>
-          <p:cNvSpPr/>
-          <p:nvPr/>
-        </p:nvSpPr>
-        <p:spPr>
-          <a:xfrm>
-            <a:off x="3474720" y="1828800"/>
-            <a:ext cx="2560320" cy="914400"/>
+          <p:cNvPr id="36" name="Text 34"/>
+          <p:cNvSpPr/>
+          <p:nvPr/>
+        </p:nvSpPr>
+        <p:spPr>
+          <a:xfrm>
+            <a:off x="4114800" y="1828800"/>
+            <a:ext cx="548640" cy="548640"/>
+          </a:xfrm>
+          <a:prstGeom prst="rect">
+            <a:avLst/>
+          </a:prstGeom>
+          <a:noFill/>
+          <a:ln/>
+        </p:spPr>
+        <p:txBody>
+          <a:bodyPr wrap="square" lIns="0" tIns="0" rIns="0" bIns="0" rtlCol="0" anchor="ctr"/>
+          <a:lstStyle/>
+          <a:p>
+            <a:pPr algn="ctr" indent="0" marL="0">
+              <a:buNone/>
+            </a:pPr>
+            <a:r>
+              <a:rPr lang="en-US" sz="3200" b="1" dirty="0">
+                <a:solidFill>
+                  <a:srgbClr val="F39C12"/>
+                </a:solidFill>
+                <a:latin typeface="Calibri" pitchFamily="34" charset="0"/>
+                <a:ea typeface="Calibri" pitchFamily="34" charset="-122"/>
+                <a:cs typeface="Calibri" pitchFamily="34" charset="-120"/>
+              </a:rPr>
+              <a:t>→</a:t>
+            </a:r>
+            <a:endParaRPr lang="en-US" sz="3200" dirty="0"/>
+          </a:p>
+        </p:txBody>
+      </p:sp>
+      <p:sp>
+        <p:nvSpPr>
+          <p:cNvPr id="37" name="Text 35"/>
+          <p:cNvSpPr/>
+          <p:nvPr/>
+        </p:nvSpPr>
+        <p:spPr>
+          <a:xfrm>
+            <a:off x="4023360" y="2286000"/>
+            <a:ext cx="731520" cy="274320"/>
+          </a:xfrm>
+          <a:prstGeom prst="rect">
+            <a:avLst/>
+          </a:prstGeom>
+          <a:noFill/>
+          <a:ln/>
+        </p:spPr>
+        <p:txBody>
+          <a:bodyPr wrap="square" lIns="0" tIns="0" rIns="0" bIns="0" rtlCol="0" anchor="ctr"/>
+          <a:lstStyle/>
+          <a:p>
+            <a:pPr algn="ctr" indent="0" marL="0">
+              <a:buNone/>
+            </a:pPr>
+            <a:r>
+              <a:rPr lang="en-US" sz="1000" dirty="0">
+                <a:solidFill>
+                  <a:srgbClr val="F39C12"/>
+                </a:solidFill>
+                <a:latin typeface="Calibri" pitchFamily="34" charset="0"/>
+                <a:ea typeface="Calibri" pitchFamily="34" charset="-122"/>
+                <a:cs typeface="Calibri" pitchFamily="34" charset="-120"/>
+              </a:rPr>
+              <a:t>Spark</a:t>
+            </a:r>
+            <a:endParaRPr lang="en-US" sz="1000" dirty="0"/>
+          </a:p>
+        </p:txBody>
+      </p:sp>
+      <p:sp>
+        <p:nvSpPr>
+          <p:cNvPr id="38" name="Text 36"/>
+          <p:cNvSpPr/>
+          <p:nvPr/>
+        </p:nvSpPr>
+        <p:spPr>
+          <a:xfrm>
+            <a:off x="4754880" y="1005840"/>
+            <a:ext cx="4023360" cy="274320"/>
+          </a:xfrm>
+          <a:prstGeom prst="rect">
+            <a:avLst/>
+          </a:prstGeom>
+          <a:noFill/>
+          <a:ln/>
+        </p:spPr>
+        <p:txBody>
+          <a:bodyPr wrap="square" lIns="0" tIns="0" rIns="0" bIns="0" rtlCol="0" anchor="ctr"/>
+          <a:lstStyle/>
+          <a:p>
+            <a:pPr algn="ctr" indent="0" marL="0">
+              <a:buNone/>
+            </a:pPr>
+            <a:r>
+              <a:rPr lang="en-US" sz="1300" b="1" dirty="0">
+                <a:solidFill>
+                  <a:srgbClr val="FFFFFF"/>
+                </a:solidFill>
+                <a:latin typeface="Calibri" pitchFamily="34" charset="0"/>
+                <a:ea typeface="Calibri" pitchFamily="34" charset="-122"/>
+                <a:cs typeface="Calibri" pitchFamily="34" charset="-120"/>
+              </a:rPr>
+              <a:t>Windowed Risk Signals</a:t>
+            </a:r>
+            <a:endParaRPr lang="en-US" sz="1300" dirty="0"/>
+          </a:p>
+        </p:txBody>
+      </p:sp>
+      <p:sp>
+        <p:nvSpPr>
+          <p:cNvPr id="39" name="Shape 37"/>
+          <p:cNvSpPr/>
+          <p:nvPr/>
+        </p:nvSpPr>
+        <p:spPr>
+          <a:xfrm>
+            <a:off x="4846320" y="1371600"/>
+            <a:ext cx="3840480" cy="640080"/>
           </a:xfrm>
           <a:prstGeom prst="rect">
             <a:avLst/>
@@ -9581,26 +10196,26 @@
       </p:sp>
       <p:sp>
         <p:nvSpPr>
-          <p:cNvPr id="14" name="Text 12"/>
-          <p:cNvSpPr/>
-          <p:nvPr/>
-        </p:nvSpPr>
-        <p:spPr>
-          <a:xfrm>
-            <a:off x="3474720" y="1828800"/>
-            <a:ext cx="2560320" cy="457200"/>
-          </a:xfrm>
-          <a:prstGeom prst="rect">
-            <a:avLst/>
-          </a:prstGeom>
-          <a:noFill/>
-          <a:ln/>
-        </p:spPr>
-        <p:txBody>
-          <a:bodyPr wrap="square" lIns="0" tIns="0" rIns="0" bIns="0" rtlCol="0" anchor="ctr"/>
-          <a:lstStyle/>
-          <a:p>
-            <a:pPr algn="ctr" indent="0" marL="0">
+          <p:cNvPr id="40" name="Text 38"/>
+          <p:cNvSpPr/>
+          <p:nvPr/>
+        </p:nvSpPr>
+        <p:spPr>
+          <a:xfrm>
+            <a:off x="5029200" y="1371600"/>
+            <a:ext cx="2286000" cy="320040"/>
+          </a:xfrm>
+          <a:prstGeom prst="rect">
+            <a:avLst/>
+          </a:prstGeom>
+          <a:noFill/>
+          <a:ln/>
+        </p:spPr>
+        <p:txBody>
+          <a:bodyPr wrap="square" lIns="0" tIns="0" rIns="0" bIns="0" rtlCol="0" anchor="ctr"/>
+          <a:lstStyle/>
+          <a:p>
+            <a:pPr indent="0" marL="0">
               <a:buNone/>
             </a:pPr>
             <a:r>
@@ -9612,24 +10227,85 @@
                 <a:ea typeface="Consolas" pitchFamily="34" charset="-122"/>
                 <a:cs typeface="Consolas" pitchFamily="34" charset="-120"/>
               </a:rPr>
-              <a:t>Window 2</a:t>
+              <a:t>Acct 12345  |  :00–:60</a:t>
             </a:r>
             <a:endParaRPr lang="en-US" sz="1000" dirty="0"/>
           </a:p>
-          <a:p>
-            <a:pPr algn="ctr" indent="0" marL="0">
+        </p:txBody>
+      </p:sp>
+      <p:sp>
+        <p:nvSpPr>
+          <p:cNvPr id="41" name="Text 39"/>
+          <p:cNvSpPr/>
+          <p:nvPr/>
+        </p:nvSpPr>
+        <p:spPr>
+          <a:xfrm>
+            <a:off x="7498080" y="1371600"/>
+            <a:ext cx="1005840" cy="320040"/>
+          </a:xfrm>
+          <a:prstGeom prst="rect">
+            <a:avLst/>
+          </a:prstGeom>
+          <a:noFill/>
+          <a:ln/>
+        </p:spPr>
+        <p:txBody>
+          <a:bodyPr wrap="square" lIns="0" tIns="0" rIns="0" bIns="0" rtlCol="0" anchor="ctr"/>
+          <a:lstStyle/>
+          <a:p>
+            <a:pPr algn="r" indent="0" marL="0">
+              <a:buNone/>
+            </a:pPr>
+            <a:r>
+              <a:rPr lang="en-US" sz="1100" b="1" dirty="0">
+                <a:solidFill>
+                  <a:srgbClr val="27AE60"/>
+                </a:solidFill>
+                <a:latin typeface="Calibri" pitchFamily="34" charset="0"/>
+                <a:ea typeface="Calibri" pitchFamily="34" charset="-122"/>
+                <a:cs typeface="Calibri" pitchFamily="34" charset="-120"/>
+              </a:rPr>
+              <a:t>NORMAL</a:t>
+            </a:r>
+            <a:endParaRPr lang="en-US" sz="1100" dirty="0"/>
+          </a:p>
+        </p:txBody>
+      </p:sp>
+      <p:sp>
+        <p:nvSpPr>
+          <p:cNvPr id="42" name="Text 40"/>
+          <p:cNvSpPr/>
+          <p:nvPr/>
+        </p:nvSpPr>
+        <p:spPr>
+          <a:xfrm>
+            <a:off x="5029200" y="1691640"/>
+            <a:ext cx="3474720" cy="274320"/>
+          </a:xfrm>
+          <a:prstGeom prst="rect">
+            <a:avLst/>
+          </a:prstGeom>
+          <a:noFill/>
+          <a:ln/>
+        </p:spPr>
+        <p:txBody>
+          <a:bodyPr wrap="square" lIns="0" tIns="0" rIns="0" bIns="0" rtlCol="0" anchor="ctr"/>
+          <a:lstStyle/>
+          <a:p>
+            <a:pPr indent="0" marL="0">
               <a:buNone/>
             </a:pPr>
             <a:r>
               <a:rPr lang="en-US" sz="1000" dirty="0">
                 <a:solidFill>
-                  <a:srgbClr val="27AE60"/>
+                  <a:srgbClr val="A0AEC0"/>
                 </a:solidFill>
                 <a:latin typeface="Consolas" pitchFamily="34" charset="0"/>
                 <a:ea typeface="Consolas" pitchFamily="34" charset="-122"/>
                 <a:cs typeface="Consolas" pitchFamily="34" charset="-120"/>
               </a:rPr>
-              <a:t>:00 – :60</a:t>
+              <a:t>12 orders  |  $48K  |  4 symbols</a:t>
             </a:r>
             <a:endParaRPr lang="en-US" sz="1000" dirty="0"/>
           </a:p>
@@ -9637,184 +10313,24 @@
       </p:sp>
       <p:sp>
         <p:nvSpPr>
-          <p:cNvPr id="15" name="Shape 13"/>
-          <p:cNvSpPr/>
-          <p:nvPr/>
-        </p:nvSpPr>
-        <p:spPr>
-          <a:xfrm>
-            <a:off x="3657600" y="2286000"/>
-            <a:ext cx="109728" cy="109728"/>
-          </a:xfrm>
-          <a:prstGeom prst="ellipse">
-            <a:avLst/>
-          </a:prstGeom>
-          <a:solidFill>
-            <a:srgbClr val="27AE60"/>
-          </a:solidFill>
-          <a:ln/>
-        </p:spPr>
-      </p:sp>
-      <p:sp>
-        <p:nvSpPr>
-          <p:cNvPr id="16" name="Shape 14"/>
-          <p:cNvSpPr/>
-          <p:nvPr/>
-        </p:nvSpPr>
-        <p:spPr>
-          <a:xfrm>
-            <a:off x="3977640" y="2286000"/>
-            <a:ext cx="109728" cy="109728"/>
-          </a:xfrm>
-          <a:prstGeom prst="ellipse">
-            <a:avLst/>
-          </a:prstGeom>
-          <a:solidFill>
-            <a:srgbClr val="27AE60"/>
-          </a:solidFill>
-          <a:ln/>
-        </p:spPr>
-      </p:sp>
-      <p:sp>
-        <p:nvSpPr>
-          <p:cNvPr id="17" name="Shape 15"/>
-          <p:cNvSpPr/>
-          <p:nvPr/>
-        </p:nvSpPr>
-        <p:spPr>
-          <a:xfrm>
-            <a:off x="4297680" y="2286000"/>
-            <a:ext cx="109728" cy="109728"/>
-          </a:xfrm>
-          <a:prstGeom prst="ellipse">
-            <a:avLst/>
-          </a:prstGeom>
-          <a:solidFill>
-            <a:srgbClr val="27AE60"/>
-          </a:solidFill>
-          <a:ln/>
-        </p:spPr>
-      </p:sp>
-      <p:sp>
-        <p:nvSpPr>
-          <p:cNvPr id="18" name="Shape 16"/>
-          <p:cNvSpPr/>
-          <p:nvPr/>
-        </p:nvSpPr>
-        <p:spPr>
-          <a:xfrm>
-            <a:off x="4617720" y="2286000"/>
-            <a:ext cx="109728" cy="109728"/>
-          </a:xfrm>
-          <a:prstGeom prst="ellipse">
-            <a:avLst/>
-          </a:prstGeom>
-          <a:solidFill>
-            <a:srgbClr val="27AE60"/>
-          </a:solidFill>
-          <a:ln/>
-        </p:spPr>
-      </p:sp>
-      <p:sp>
-        <p:nvSpPr>
-          <p:cNvPr id="19" name="Shape 17"/>
-          <p:cNvSpPr/>
-          <p:nvPr/>
-        </p:nvSpPr>
-        <p:spPr>
-          <a:xfrm>
-            <a:off x="4937760" y="2286000"/>
-            <a:ext cx="109728" cy="109728"/>
-          </a:xfrm>
-          <a:prstGeom prst="ellipse">
-            <a:avLst/>
-          </a:prstGeom>
-          <a:solidFill>
-            <a:srgbClr val="27AE60"/>
-          </a:solidFill>
-          <a:ln/>
-        </p:spPr>
-      </p:sp>
-      <p:sp>
-        <p:nvSpPr>
-          <p:cNvPr id="20" name="Shape 18"/>
-          <p:cNvSpPr/>
-          <p:nvPr/>
-        </p:nvSpPr>
-        <p:spPr>
-          <a:xfrm>
-            <a:off x="5257800" y="2286000"/>
-            <a:ext cx="109728" cy="109728"/>
-          </a:xfrm>
-          <a:prstGeom prst="ellipse">
-            <a:avLst/>
-          </a:prstGeom>
-          <a:solidFill>
-            <a:srgbClr val="27AE60"/>
-          </a:solidFill>
-          <a:ln/>
-        </p:spPr>
-      </p:sp>
-      <p:sp>
-        <p:nvSpPr>
-          <p:cNvPr id="21" name="Shape 19"/>
-          <p:cNvSpPr/>
-          <p:nvPr/>
-        </p:nvSpPr>
-        <p:spPr>
-          <a:xfrm>
-            <a:off x="5577840" y="2286000"/>
-            <a:ext cx="109728" cy="109728"/>
-          </a:xfrm>
-          <a:prstGeom prst="ellipse">
-            <a:avLst/>
-          </a:prstGeom>
-          <a:solidFill>
-            <a:srgbClr val="27AE60"/>
-          </a:solidFill>
-          <a:ln/>
-        </p:spPr>
-      </p:sp>
-      <p:sp>
-        <p:nvSpPr>
-          <p:cNvPr id="22" name="Shape 20"/>
-          <p:cNvSpPr/>
-          <p:nvPr/>
-        </p:nvSpPr>
-        <p:spPr>
-          <a:xfrm>
-            <a:off x="3657600" y="2514600"/>
-            <a:ext cx="109728" cy="109728"/>
-          </a:xfrm>
-          <a:prstGeom prst="ellipse">
-            <a:avLst/>
-          </a:prstGeom>
-          <a:solidFill>
-            <a:srgbClr val="27AE60"/>
-          </a:solidFill>
-          <a:ln/>
-        </p:spPr>
-      </p:sp>
-      <p:sp>
-        <p:nvSpPr>
-          <p:cNvPr id="23" name="Shape 21"/>
-          <p:cNvSpPr/>
-          <p:nvPr/>
-        </p:nvSpPr>
-        <p:spPr>
-          <a:xfrm>
-            <a:off x="6217920" y="1828800"/>
-            <a:ext cx="2560320" cy="914400"/>
-          </a:xfrm>
-          <a:prstGeom prst="rect">
-            <a:avLst/>
-          </a:prstGeom>
-          <a:solidFill>
-            <a:srgbClr val="232842"/>
+          <p:cNvPr id="43" name="Shape 41"/>
+          <p:cNvSpPr/>
+          <p:nvPr/>
+        </p:nvSpPr>
+        <p:spPr>
+          <a:xfrm>
+            <a:off x="4846320" y="2148840"/>
+            <a:ext cx="3840480" cy="640080"/>
+          </a:xfrm>
+          <a:prstGeom prst="rect">
+            <a:avLst/>
+          </a:prstGeom>
+          <a:solidFill>
+            <a:srgbClr val="2A1520"/>
           </a:solidFill>
           <a:ln w="25400">
             <a:solidFill>
-              <a:srgbClr val="F39C12"/>
+              <a:srgbClr val="E74C3C"/>
             </a:solidFill>
             <a:prstDash val="solid"/>
           </a:ln>
@@ -9822,55 +10338,116 @@
       </p:sp>
       <p:sp>
         <p:nvSpPr>
-          <p:cNvPr id="24" name="Text 22"/>
-          <p:cNvSpPr/>
-          <p:nvPr/>
-        </p:nvSpPr>
-        <p:spPr>
-          <a:xfrm>
-            <a:off x="6217920" y="1828800"/>
-            <a:ext cx="2560320" cy="457200"/>
-          </a:xfrm>
-          <a:prstGeom prst="rect">
-            <a:avLst/>
-          </a:prstGeom>
-          <a:noFill/>
-          <a:ln/>
-        </p:spPr>
-        <p:txBody>
-          <a:bodyPr wrap="square" lIns="0" tIns="0" rIns="0" bIns="0" rtlCol="0" anchor="ctr"/>
-          <a:lstStyle/>
-          <a:p>
-            <a:pPr algn="ctr" indent="0" marL="0">
+          <p:cNvPr id="44" name="Text 42"/>
+          <p:cNvSpPr/>
+          <p:nvPr/>
+        </p:nvSpPr>
+        <p:spPr>
+          <a:xfrm>
+            <a:off x="5029200" y="2148840"/>
+            <a:ext cx="2286000" cy="320040"/>
+          </a:xfrm>
+          <a:prstGeom prst="rect">
+            <a:avLst/>
+          </a:prstGeom>
+          <a:noFill/>
+          <a:ln/>
+        </p:spPr>
+        <p:txBody>
+          <a:bodyPr wrap="square" lIns="0" tIns="0" rIns="0" bIns="0" rtlCol="0" anchor="ctr"/>
+          <a:lstStyle/>
+          <a:p>
+            <a:pPr indent="0" marL="0">
               <a:buNone/>
             </a:pPr>
             <a:r>
               <a:rPr lang="en-US" sz="1000" dirty="0">
                 <a:solidFill>
-                  <a:srgbClr val="F39C12"/>
+                  <a:srgbClr val="E74C3C"/>
                 </a:solidFill>
                 <a:latin typeface="Consolas" pitchFamily="34" charset="0"/>
                 <a:ea typeface="Consolas" pitchFamily="34" charset="-122"/>
                 <a:cs typeface="Consolas" pitchFamily="34" charset="-120"/>
               </a:rPr>
-              <a:t>Window 3</a:t>
+              <a:t>Acct 67890  |  :00–:60</a:t>
             </a:r>
             <a:endParaRPr lang="en-US" sz="1000" dirty="0"/>
           </a:p>
-          <a:p>
-            <a:pPr algn="ctr" indent="0" marL="0">
+        </p:txBody>
+      </p:sp>
+      <p:sp>
+        <p:nvSpPr>
+          <p:cNvPr id="45" name="Text 43"/>
+          <p:cNvSpPr/>
+          <p:nvPr/>
+        </p:nvSpPr>
+        <p:spPr>
+          <a:xfrm>
+            <a:off x="7498080" y="2148840"/>
+            <a:ext cx="1005840" cy="320040"/>
+          </a:xfrm>
+          <a:prstGeom prst="rect">
+            <a:avLst/>
+          </a:prstGeom>
+          <a:noFill/>
+          <a:ln/>
+        </p:spPr>
+        <p:txBody>
+          <a:bodyPr wrap="square" lIns="0" tIns="0" rIns="0" bIns="0" rtlCol="0" anchor="ctr"/>
+          <a:lstStyle/>
+          <a:p>
+            <a:pPr algn="r" indent="0" marL="0">
+              <a:buNone/>
+            </a:pPr>
+            <a:r>
+              <a:rPr lang="en-US" sz="1100" b="1" dirty="0">
+                <a:solidFill>
+                  <a:srgbClr val="E74C3C"/>
+                </a:solidFill>
+                <a:latin typeface="Calibri" pitchFamily="34" charset="0"/>
+                <a:ea typeface="Calibri" pitchFamily="34" charset="-122"/>
+                <a:cs typeface="Calibri" pitchFamily="34" charset="-120"/>
+              </a:rPr>
+              <a:t>BREACH</a:t>
+            </a:r>
+            <a:endParaRPr lang="en-US" sz="1100" dirty="0"/>
+          </a:p>
+        </p:txBody>
+      </p:sp>
+      <p:sp>
+        <p:nvSpPr>
+          <p:cNvPr id="46" name="Text 44"/>
+          <p:cNvSpPr/>
+          <p:nvPr/>
+        </p:nvSpPr>
+        <p:spPr>
+          <a:xfrm>
+            <a:off x="5029200" y="2468880"/>
+            <a:ext cx="3474720" cy="274320"/>
+          </a:xfrm>
+          <a:prstGeom prst="rect">
+            <a:avLst/>
+          </a:prstGeom>
+          <a:noFill/>
+          <a:ln/>
+        </p:spPr>
+        <p:txBody>
+          <a:bodyPr wrap="square" lIns="0" tIns="0" rIns="0" bIns="0" rtlCol="0" anchor="ctr"/>
+          <a:lstStyle/>
+          <a:p>
+            <a:pPr indent="0" marL="0">
               <a:buNone/>
             </a:pPr>
             <a:r>
               <a:rPr lang="en-US" sz="1000" dirty="0">
                 <a:solidFill>
-                  <a:srgbClr val="F39C12"/>
+                  <a:srgbClr val="E74C3C"/>
                 </a:solidFill>
                 <a:latin typeface="Consolas" pitchFamily="34" charset="0"/>
                 <a:ea typeface="Consolas" pitchFamily="34" charset="-122"/>
                 <a:cs typeface="Consolas" pitchFamily="34" charset="-120"/>
               </a:rPr>
-              <a:t>:00 – :60</a:t>
+              <a:t>147 orders  |  $1.2M  |  92% AAPL</a:t>
             </a:r>
             <a:endParaRPr lang="en-US" sz="1000" dirty="0"/>
           </a:p>
@@ -9878,287 +10455,133 @@
       </p:sp>
       <p:sp>
         <p:nvSpPr>
-          <p:cNvPr id="25" name="Shape 23"/>
-          <p:cNvSpPr/>
-          <p:nvPr/>
-        </p:nvSpPr>
-        <p:spPr>
-          <a:xfrm>
-            <a:off x="6400800" y="2286000"/>
-            <a:ext cx="109728" cy="109728"/>
-          </a:xfrm>
-          <a:prstGeom prst="ellipse">
-            <a:avLst/>
-          </a:prstGeom>
-          <a:solidFill>
-            <a:srgbClr val="F39C12"/>
-          </a:solidFill>
-          <a:ln/>
-        </p:spPr>
-      </p:sp>
-      <p:sp>
-        <p:nvSpPr>
-          <p:cNvPr id="26" name="Shape 24"/>
-          <p:cNvSpPr/>
-          <p:nvPr/>
-        </p:nvSpPr>
-        <p:spPr>
-          <a:xfrm>
-            <a:off x="6720840" y="2286000"/>
-            <a:ext cx="109728" cy="109728"/>
-          </a:xfrm>
-          <a:prstGeom prst="ellipse">
-            <a:avLst/>
-          </a:prstGeom>
-          <a:solidFill>
-            <a:srgbClr val="F39C12"/>
-          </a:solidFill>
-          <a:ln/>
-        </p:spPr>
-      </p:sp>
-      <p:sp>
-        <p:nvSpPr>
-          <p:cNvPr id="27" name="Shape 25"/>
-          <p:cNvSpPr/>
-          <p:nvPr/>
-        </p:nvSpPr>
-        <p:spPr>
-          <a:xfrm>
-            <a:off x="7040880" y="2286000"/>
-            <a:ext cx="109728" cy="109728"/>
-          </a:xfrm>
-          <a:prstGeom prst="ellipse">
-            <a:avLst/>
-          </a:prstGeom>
-          <a:solidFill>
-            <a:srgbClr val="F39C12"/>
-          </a:solidFill>
-          <a:ln/>
-        </p:spPr>
-      </p:sp>
-      <p:sp>
-        <p:nvSpPr>
-          <p:cNvPr id="28" name="Shape 26"/>
-          <p:cNvSpPr/>
-          <p:nvPr/>
-        </p:nvSpPr>
-        <p:spPr>
-          <a:xfrm>
-            <a:off x="7360920" y="2286000"/>
-            <a:ext cx="109728" cy="109728"/>
-          </a:xfrm>
-          <a:prstGeom prst="ellipse">
-            <a:avLst/>
-          </a:prstGeom>
-          <a:solidFill>
-            <a:srgbClr val="F39C12"/>
-          </a:solidFill>
-          <a:ln/>
-        </p:spPr>
-      </p:sp>
-      <p:sp>
-        <p:nvSpPr>
-          <p:cNvPr id="29" name="Shape 27"/>
-          <p:cNvSpPr/>
-          <p:nvPr/>
-        </p:nvSpPr>
-        <p:spPr>
-          <a:xfrm>
-            <a:off x="7680960" y="2286000"/>
-            <a:ext cx="109728" cy="109728"/>
-          </a:xfrm>
-          <a:prstGeom prst="ellipse">
-            <a:avLst/>
-          </a:prstGeom>
-          <a:solidFill>
-            <a:srgbClr val="F39C12"/>
-          </a:solidFill>
-          <a:ln/>
-        </p:spPr>
-      </p:sp>
-      <p:sp>
-        <p:nvSpPr>
-          <p:cNvPr id="30" name="Shape 28"/>
-          <p:cNvSpPr/>
-          <p:nvPr/>
-        </p:nvSpPr>
-        <p:spPr>
-          <a:xfrm>
-            <a:off x="8001000" y="2286000"/>
-            <a:ext cx="109728" cy="109728"/>
-          </a:xfrm>
-          <a:prstGeom prst="ellipse">
-            <a:avLst/>
-          </a:prstGeom>
-          <a:solidFill>
-            <a:srgbClr val="F39C12"/>
-          </a:solidFill>
-          <a:ln/>
-        </p:spPr>
-      </p:sp>
-      <p:sp>
-        <p:nvSpPr>
-          <p:cNvPr id="31" name="Shape 29"/>
-          <p:cNvSpPr/>
-          <p:nvPr/>
-        </p:nvSpPr>
-        <p:spPr>
-          <a:xfrm>
-            <a:off x="8321040" y="2286000"/>
-            <a:ext cx="109728" cy="109728"/>
-          </a:xfrm>
-          <a:prstGeom prst="ellipse">
-            <a:avLst/>
-          </a:prstGeom>
-          <a:solidFill>
-            <a:srgbClr val="F39C12"/>
-          </a:solidFill>
-          <a:ln/>
-        </p:spPr>
-      </p:sp>
-      <p:sp>
-        <p:nvSpPr>
-          <p:cNvPr id="32" name="Shape 30"/>
-          <p:cNvSpPr/>
-          <p:nvPr/>
-        </p:nvSpPr>
-        <p:spPr>
-          <a:xfrm>
-            <a:off x="6400800" y="2514600"/>
-            <a:ext cx="109728" cy="109728"/>
-          </a:xfrm>
-          <a:prstGeom prst="ellipse">
-            <a:avLst/>
-          </a:prstGeom>
-          <a:solidFill>
-            <a:srgbClr val="F39C12"/>
-          </a:solidFill>
-          <a:ln/>
-        </p:spPr>
-      </p:sp>
-      <p:sp>
-        <p:nvSpPr>
-          <p:cNvPr id="33" name="Shape 31"/>
-          <p:cNvSpPr/>
-          <p:nvPr/>
-        </p:nvSpPr>
-        <p:spPr>
-          <a:xfrm>
-            <a:off x="6720840" y="2514600"/>
-            <a:ext cx="109728" cy="109728"/>
-          </a:xfrm>
-          <a:prstGeom prst="ellipse">
-            <a:avLst/>
-          </a:prstGeom>
-          <a:solidFill>
-            <a:srgbClr val="F39C12"/>
-          </a:solidFill>
-          <a:ln/>
-        </p:spPr>
-      </p:sp>
-      <p:sp>
-        <p:nvSpPr>
-          <p:cNvPr id="34" name="Shape 32"/>
-          <p:cNvSpPr/>
-          <p:nvPr/>
-        </p:nvSpPr>
-        <p:spPr>
-          <a:xfrm>
-            <a:off x="7040880" y="2514600"/>
-            <a:ext cx="109728" cy="109728"/>
-          </a:xfrm>
-          <a:prstGeom prst="ellipse">
-            <a:avLst/>
-          </a:prstGeom>
-          <a:solidFill>
-            <a:srgbClr val="F39C12"/>
-          </a:solidFill>
-          <a:ln/>
-        </p:spPr>
-      </p:sp>
-      <p:sp>
-        <p:nvSpPr>
-          <p:cNvPr id="35" name="Shape 33"/>
-          <p:cNvSpPr/>
-          <p:nvPr/>
-        </p:nvSpPr>
-        <p:spPr>
-          <a:xfrm>
-            <a:off x="7360920" y="2514600"/>
-            <a:ext cx="109728" cy="109728"/>
-          </a:xfrm>
-          <a:prstGeom prst="ellipse">
-            <a:avLst/>
-          </a:prstGeom>
-          <a:solidFill>
-            <a:srgbClr val="F39C12"/>
-          </a:solidFill>
-          <a:ln/>
-        </p:spPr>
-      </p:sp>
-      <p:sp>
-        <p:nvSpPr>
-          <p:cNvPr id="36" name="Shape 34"/>
-          <p:cNvSpPr/>
-          <p:nvPr/>
-        </p:nvSpPr>
-        <p:spPr>
-          <a:xfrm>
-            <a:off x="731520" y="3017520"/>
-            <a:ext cx="7680960" cy="1645920"/>
-          </a:xfrm>
-          <a:prstGeom prst="rect">
-            <a:avLst/>
-          </a:prstGeom>
-          <a:solidFill>
-            <a:srgbClr val="171B2E"/>
-          </a:solidFill>
-          <a:ln/>
-        </p:spPr>
-      </p:sp>
-      <p:sp>
-        <p:nvSpPr>
-          <p:cNvPr id="37" name="Text 35"/>
-          <p:cNvSpPr/>
-          <p:nvPr/>
-        </p:nvSpPr>
-        <p:spPr>
-          <a:xfrm>
-            <a:off x="914400" y="3108960"/>
-            <a:ext cx="7315200" cy="1463040"/>
-          </a:xfrm>
-          <a:prstGeom prst="rect">
-            <a:avLst/>
-          </a:prstGeom>
-          <a:noFill/>
-          <a:ln/>
-        </p:spPr>
-        <p:txBody>
-          <a:bodyPr wrap="square" lIns="0" tIns="0" rIns="0" bIns="0" rtlCol="0" anchor="ctr"/>
-          <a:lstStyle/>
-          <a:p>
-            <a:pPr indent="0" marL="0">
-              <a:buNone/>
-            </a:pPr>
-            <a:r>
-              <a:rPr lang="en-US" sz="1200" dirty="0">
-                <a:solidFill>
-                  <a:srgbClr val="A0AEC0"/>
+          <p:cNvPr id="47" name="Shape 45"/>
+          <p:cNvSpPr/>
+          <p:nvPr/>
+        </p:nvSpPr>
+        <p:spPr>
+          <a:xfrm>
+            <a:off x="4846320" y="2926080"/>
+            <a:ext cx="3840480" cy="640080"/>
+          </a:xfrm>
+          <a:prstGeom prst="rect">
+            <a:avLst/>
+          </a:prstGeom>
+          <a:solidFill>
+            <a:srgbClr val="232842"/>
+          </a:solidFill>
+          <a:ln w="25400">
+            <a:solidFill>
+              <a:srgbClr val="27AE60"/>
+            </a:solidFill>
+            <a:prstDash val="solid"/>
+          </a:ln>
+        </p:spPr>
+      </p:sp>
+      <p:sp>
+        <p:nvSpPr>
+          <p:cNvPr id="48" name="Text 46"/>
+          <p:cNvSpPr/>
+          <p:nvPr/>
+        </p:nvSpPr>
+        <p:spPr>
+          <a:xfrm>
+            <a:off x="5029200" y="2926080"/>
+            <a:ext cx="2286000" cy="320040"/>
+          </a:xfrm>
+          <a:prstGeom prst="rect">
+            <a:avLst/>
+          </a:prstGeom>
+          <a:noFill/>
+          <a:ln/>
+        </p:spPr>
+        <p:txBody>
+          <a:bodyPr wrap="square" lIns="0" tIns="0" rIns="0" bIns="0" rtlCol="0" anchor="ctr"/>
+          <a:lstStyle/>
+          <a:p>
+            <a:pPr indent="0" marL="0">
+              <a:buNone/>
+            </a:pPr>
+            <a:r>
+              <a:rPr lang="en-US" sz="1000" dirty="0">
+                <a:solidFill>
+                  <a:srgbClr val="27AE60"/>
                 </a:solidFill>
                 <a:latin typeface="Consolas" pitchFamily="34" charset="0"/>
                 <a:ea typeface="Consolas" pitchFamily="34" charset="-122"/>
                 <a:cs typeface="Consolas" pitchFamily="34" charset="-120"/>
               </a:rPr>
-              <a:t>orders_df</a:t>
-            </a:r>
-            <a:endParaRPr lang="en-US" sz="1200" dirty="0"/>
-          </a:p>
-          <a:p>
-            <a:pPr indent="0" marL="0">
-              <a:buNone/>
-            </a:pPr>
-            <a:r>
-              <a:rPr lang="en-US" sz="1200" dirty="0">
+              <a:t>Acct 54321  |  :00–:60</a:t>
+            </a:r>
+            <a:endParaRPr lang="en-US" sz="1000" dirty="0"/>
+          </a:p>
+        </p:txBody>
+      </p:sp>
+      <p:sp>
+        <p:nvSpPr>
+          <p:cNvPr id="49" name="Text 47"/>
+          <p:cNvSpPr/>
+          <p:nvPr/>
+        </p:nvSpPr>
+        <p:spPr>
+          <a:xfrm>
+            <a:off x="7498080" y="2926080"/>
+            <a:ext cx="1005840" cy="320040"/>
+          </a:xfrm>
+          <a:prstGeom prst="rect">
+            <a:avLst/>
+          </a:prstGeom>
+          <a:noFill/>
+          <a:ln/>
+        </p:spPr>
+        <p:txBody>
+          <a:bodyPr wrap="square" lIns="0" tIns="0" rIns="0" bIns="0" rtlCol="0" anchor="ctr"/>
+          <a:lstStyle/>
+          <a:p>
+            <a:pPr algn="r" indent="0" marL="0">
+              <a:buNone/>
+            </a:pPr>
+            <a:r>
+              <a:rPr lang="en-US" sz="1100" b="1" dirty="0">
+                <a:solidFill>
+                  <a:srgbClr val="27AE60"/>
+                </a:solidFill>
+                <a:latin typeface="Calibri" pitchFamily="34" charset="0"/>
+                <a:ea typeface="Calibri" pitchFamily="34" charset="-122"/>
+                <a:cs typeface="Calibri" pitchFamily="34" charset="-120"/>
+              </a:rPr>
+              <a:t>NORMAL</a:t>
+            </a:r>
+            <a:endParaRPr lang="en-US" sz="1100" dirty="0"/>
+          </a:p>
+        </p:txBody>
+      </p:sp>
+      <p:sp>
+        <p:nvSpPr>
+          <p:cNvPr id="50" name="Text 48"/>
+          <p:cNvSpPr/>
+          <p:nvPr/>
+        </p:nvSpPr>
+        <p:spPr>
+          <a:xfrm>
+            <a:off x="5029200" y="3246120"/>
+            <a:ext cx="3474720" cy="274320"/>
+          </a:xfrm>
+          <a:prstGeom prst="rect">
+            <a:avLst/>
+          </a:prstGeom>
+          <a:noFill/>
+          <a:ln/>
+        </p:spPr>
+        <p:txBody>
+          <a:bodyPr wrap="square" lIns="0" tIns="0" rIns="0" bIns="0" rtlCol="0" anchor="ctr"/>
+          <a:lstStyle/>
+          <a:p>
+            <a:pPr indent="0" marL="0">
+              <a:buNone/>
+            </a:pPr>
+            <a:r>
+              <a:rPr lang="en-US" sz="1000" dirty="0">
                 <a:solidFill>
                   <a:srgbClr val="A0AEC0"/>
                 </a:solidFill>
@@ -10166,16 +10589,97 @@
                 <a:ea typeface="Consolas" pitchFamily="34" charset="-122"/>
                 <a:cs typeface="Consolas" pitchFamily="34" charset="-120"/>
               </a:rPr>
-              <a:t>  .withWatermark("event_time", "60 seconds")</a:t>
-            </a:r>
-            <a:endParaRPr lang="en-US" sz="1200" dirty="0"/>
-          </a:p>
-          <a:p>
-            <a:pPr indent="0" marL="0">
-              <a:buNone/>
-            </a:pPr>
-            <a:r>
-              <a:rPr lang="en-US" sz="1200" dirty="0">
+              <a:t>8 orders  |  $22K  |  3 symbols</a:t>
+            </a:r>
+            <a:endParaRPr lang="en-US" sz="1000" dirty="0"/>
+          </a:p>
+        </p:txBody>
+      </p:sp>
+      <p:sp>
+        <p:nvSpPr>
+          <p:cNvPr id="51" name="Text 49"/>
+          <p:cNvSpPr/>
+          <p:nvPr/>
+        </p:nvSpPr>
+        <p:spPr>
+          <a:xfrm>
+            <a:off x="4754880" y="3657600"/>
+            <a:ext cx="4023360" cy="228600"/>
+          </a:xfrm>
+          <a:prstGeom prst="rect">
+            <a:avLst/>
+          </a:prstGeom>
+          <a:noFill/>
+          <a:ln/>
+        </p:spPr>
+        <p:txBody>
+          <a:bodyPr wrap="square" lIns="0" tIns="0" rIns="0" bIns="0" rtlCol="0" anchor="ctr"/>
+          <a:lstStyle/>
+          <a:p>
+            <a:pPr algn="ctr" indent="0" marL="0">
+              <a:buNone/>
+            </a:pPr>
+            <a:r>
+              <a:rPr lang="en-US" sz="1000" i="1" dirty="0">
+                <a:solidFill>
+                  <a:srgbClr val="718096"/>
+                </a:solidFill>
+                <a:latin typeface="Calibri" pitchFamily="34" charset="0"/>
+                <a:ea typeface="Calibri" pitchFamily="34" charset="-122"/>
+                <a:cs typeface="Calibri" pitchFamily="34" charset="-120"/>
+              </a:rPr>
+              <a:t>One summary per account per 60 seconds — breaches trigger automatic KILL</a:t>
+            </a:r>
+            <a:endParaRPr lang="en-US" sz="1000" dirty="0"/>
+          </a:p>
+        </p:txBody>
+      </p:sp>
+      <p:sp>
+        <p:nvSpPr>
+          <p:cNvPr id="52" name="Shape 50"/>
+          <p:cNvSpPr/>
+          <p:nvPr/>
+        </p:nvSpPr>
+        <p:spPr>
+          <a:xfrm>
+            <a:off x="365760" y="4069080"/>
+            <a:ext cx="8412480" cy="914400"/>
+          </a:xfrm>
+          <a:prstGeom prst="rect">
+            <a:avLst/>
+          </a:prstGeom>
+          <a:solidFill>
+            <a:srgbClr val="171B2E"/>
+          </a:solidFill>
+          <a:ln/>
+        </p:spPr>
+      </p:sp>
+      <p:sp>
+        <p:nvSpPr>
+          <p:cNvPr id="53" name="Text 51"/>
+          <p:cNvSpPr/>
+          <p:nvPr/>
+        </p:nvSpPr>
+        <p:spPr>
+          <a:xfrm>
+            <a:off x="548640" y="4160520"/>
+            <a:ext cx="8046720" cy="365760"/>
+          </a:xfrm>
+          <a:prstGeom prst="rect">
+            <a:avLst/>
+          </a:prstGeom>
+          <a:noFill/>
+          <a:ln/>
+        </p:spPr>
+        <p:txBody>
+          <a:bodyPr wrap="square" lIns="0" tIns="0" rIns="0" bIns="0" rtlCol="0" anchor="ctr"/>
+          <a:lstStyle/>
+          <a:p>
+            <a:pPr indent="0" marL="0">
+              <a:buNone/>
+            </a:pPr>
+            <a:r>
+              <a:rPr lang="en-US" sz="1100" dirty="0">
                 <a:solidFill>
                   <a:srgbClr val="A0AEC0"/>
                 </a:solidFill>
@@ -10183,77 +10687,132 @@
                 <a:ea typeface="Consolas" pitchFamily="34" charset="-122"/>
                 <a:cs typeface="Consolas" pitchFamily="34" charset="-120"/>
               </a:rPr>
-              <a:t>  .groupBy(</a:t>
-            </a:r>
-            <a:endParaRPr lang="en-US" sz="1200" dirty="0"/>
-          </a:p>
-          <a:p>
-            <a:pPr indent="0" marL="0">
-              <a:buNone/>
-            </a:pPr>
-            <a:r>
-              <a:rPr lang="en-US" sz="1200" dirty="0">
-                <a:solidFill>
-                  <a:srgbClr val="4A90D9"/>
+              <a:t>.groupBy(</a:t>
+            </a:r>
+            <a:pPr indent="0" marL="0">
+              <a:buNone/>
+            </a:pPr>
+            <a:r>
+              <a:rPr lang="en-US" sz="1100" dirty="0">
+                <a:solidFill>
+                  <a:srgbClr val="F39C12"/>
                 </a:solidFill>
                 <a:latin typeface="Consolas" pitchFamily="34" charset="0"/>
                 <a:ea typeface="Consolas" pitchFamily="34" charset="-122"/>
                 <a:cs typeface="Consolas" pitchFamily="34" charset="-120"/>
               </a:rPr>
-              <a:t>      window(event_time, '60 seconds'),</a:t>
-            </a:r>
-            <a:endParaRPr lang="en-US" sz="1200" dirty="0"/>
-          </a:p>
-          <a:p>
-            <a:pPr indent="0" marL="0">
-              <a:buNone/>
-            </a:pPr>
-            <a:r>
-              <a:rPr lang="en-US" sz="1200" dirty="0">
-                <a:solidFill>
-                  <a:srgbClr val="27AE60"/>
+              <a:t>window(event_time, '60 seconds')</a:t>
+            </a:r>
+            <a:pPr indent="0" marL="0">
+              <a:buNone/>
+            </a:pPr>
+            <a:r>
+              <a:rPr lang="en-US" sz="1100" dirty="0">
+                <a:solidFill>
+                  <a:srgbClr val="A0AEC0"/>
                 </a:solidFill>
                 <a:latin typeface="Consolas" pitchFamily="34" charset="0"/>
                 <a:ea typeface="Consolas" pitchFamily="34" charset="-122"/>
                 <a:cs typeface="Consolas" pitchFamily="34" charset="-120"/>
               </a:rPr>
-              <a:t>      account_id</a:t>
-            </a:r>
-            <a:endParaRPr lang="en-US" sz="1200" dirty="0"/>
-          </a:p>
-          <a:p>
-            <a:pPr indent="0" marL="0">
-              <a:buNone/>
-            </a:pPr>
-            <a:r>
-              <a:rPr lang="en-US" sz="1200" dirty="0">
-                <a:solidFill>
-                  <a:srgbClr val="A0AEC0"/>
+              <a:t>, </a:t>
+            </a:r>
+            <a:pPr indent="0" marL="0">
+              <a:buNone/>
+            </a:pPr>
+            <a:r>
+              <a:rPr lang="en-US" sz="1100" dirty="0">
+                <a:solidFill>
+                  <a:srgbClr val="4A90D9"/>
                 </a:solidFill>
                 <a:latin typeface="Consolas" pitchFamily="34" charset="0"/>
                 <a:ea typeface="Consolas" pitchFamily="34" charset="-122"/>
                 <a:cs typeface="Consolas" pitchFamily="34" charset="-120"/>
               </a:rPr>
-              <a:t>  )</a:t>
-            </a:r>
-            <a:endParaRPr lang="en-US" sz="1200" dirty="0"/>
-          </a:p>
-          <a:p>
-            <a:pPr indent="0" marL="0">
-              <a:buNone/>
-            </a:pPr>
-            <a:r>
-              <a:rPr lang="en-US" sz="1200" dirty="0">
-                <a:solidFill>
-                  <a:srgbClr val="F39C12"/>
+              <a:t>account_id</a:t>
+            </a:r>
+            <a:pPr indent="0" marL="0">
+              <a:buNone/>
+            </a:pPr>
+            <a:r>
+              <a:rPr lang="en-US" sz="1100" dirty="0">
+                <a:solidFill>
+                  <a:srgbClr val="A0AEC0"/>
                 </a:solidFill>
                 <a:latin typeface="Consolas" pitchFamily="34" charset="0"/>
                 <a:ea typeface="Consolas" pitchFamily="34" charset="-122"/>
                 <a:cs typeface="Consolas" pitchFamily="34" charset="-120"/>
               </a:rPr>
-              <a:t>  .agg(count(*), sum(notional), collect_list(symbol))</a:t>
-            </a:r>
-            <a:endParaRPr lang="en-US" sz="1200" dirty="0"/>
+              <a:t>).agg(</a:t>
+            </a:r>
+            <a:pPr indent="0" marL="0">
+              <a:buNone/>
+            </a:pPr>
+            <a:r>
+              <a:rPr lang="en-US" sz="1100" dirty="0">
+                <a:solidFill>
+                  <a:srgbClr val="27AE60"/>
+                </a:solidFill>
+                <a:latin typeface="Consolas" pitchFamily="34" charset="0"/>
+                <a:ea typeface="Consolas" pitchFamily="34" charset="-122"/>
+                <a:cs typeface="Consolas" pitchFamily="34" charset="-120"/>
+              </a:rPr>
+              <a:t>count(*), sum(notional), collect_list(symbol)</a:t>
+            </a:r>
+            <a:pPr indent="0" marL="0">
+              <a:buNone/>
+            </a:pPr>
+            <a:r>
+              <a:rPr lang="en-US" sz="1100" dirty="0">
+                <a:solidFill>
+                  <a:srgbClr val="A0AEC0"/>
+                </a:solidFill>
+                <a:latin typeface="Consolas" pitchFamily="34" charset="0"/>
+                <a:ea typeface="Consolas" pitchFamily="34" charset="-122"/>
+                <a:cs typeface="Consolas" pitchFamily="34" charset="-120"/>
+              </a:rPr>
+              <a:t>)</a:t>
+            </a:r>
+            <a:endParaRPr lang="en-US" sz="1100" dirty="0"/>
+          </a:p>
+        </p:txBody>
+      </p:sp>
+      <p:sp>
+        <p:nvSpPr>
+          <p:cNvPr id="54" name="Text 52"/>
+          <p:cNvSpPr/>
+          <p:nvPr/>
+        </p:nvSpPr>
+        <p:spPr>
+          <a:xfrm>
+            <a:off x="548640" y="4526280"/>
+            <a:ext cx="8046720" cy="320040"/>
+          </a:xfrm>
+          <a:prstGeom prst="rect">
+            <a:avLst/>
+          </a:prstGeom>
+          <a:noFill/>
+          <a:ln/>
+        </p:spPr>
+        <p:txBody>
+          <a:bodyPr wrap="square" lIns="0" tIns="0" rIns="0" bIns="0" rtlCol="0" anchor="ctr"/>
+          <a:lstStyle/>
+          <a:p>
+            <a:pPr indent="0" marL="0">
+              <a:buNone/>
+            </a:pPr>
+            <a:r>
+              <a:rPr lang="en-US" sz="1100" dirty="0">
+                <a:solidFill>
+                  <a:srgbClr val="F39C12"/>
+                </a:solidFill>
+                <a:latin typeface="Calibri" pitchFamily="34" charset="0"/>
+                <a:ea typeface="Calibri" pitchFamily="34" charset="-122"/>
+                <a:cs typeface="Calibri" pitchFamily="34" charset="-120"/>
+              </a:rPr>
+              <a:t>Raw chaos in → structured risk signals out → automatic action on breach</a:t>
+            </a:r>
+            <a:endParaRPr lang="en-US" sz="1100" dirty="0"/>
           </a:p>
         </p:txBody>
       </p:sp>

</xml_diff>